<commit_message>
Implementacion y comprobacion del funcionamiento de las plantilla Kyu de ogkv
</commit_message>
<xml_diff>
--- a/plantillas/ogkv/ogkv_dan.pptx
+++ b/plantillas/ogkv/ogkv_dan.pptx
@@ -293,7 +293,7 @@
             <a:fld id="{BC2B9050-81BC-483D-885B-89B2CA6A4F90}" type="datetimeFigureOut">
               <a:rPr lang="es-VE" altLang="es-VE"/>
               <a:pPr/>
-              <a:t>4/3/2026</a:t>
+              <a:t>6/3/2026</a:t>
             </a:fld>
             <a:endParaRPr lang="es-VE" altLang="es-VE"/>
           </a:p>
@@ -573,7 +573,7 @@
             <a:fld id="{C37E8F85-B729-4419-89BA-5F8E71B87271}" type="datetimeFigureOut">
               <a:rPr lang="es-VE" altLang="es-VE"/>
               <a:pPr/>
-              <a:t>4/3/2026</a:t>
+              <a:t>6/3/2026</a:t>
             </a:fld>
             <a:endParaRPr lang="es-VE" altLang="es-VE"/>
           </a:p>

</xml_diff>

<commit_message>
Agregacion y Ajustes de plantillas Ocoa y OGKV
</commit_message>
<xml_diff>
--- a/plantillas/ogkv/ogkv_dan.pptx
+++ b/plantillas/ogkv/ogkv_dan.pptx
@@ -293,7 +293,7 @@
             <a:fld id="{BC2B9050-81BC-483D-885B-89B2CA6A4F90}" type="datetimeFigureOut">
               <a:rPr lang="es-VE" altLang="es-VE"/>
               <a:pPr/>
-              <a:t>6/3/2026</a:t>
+              <a:t>7/3/2026</a:t>
             </a:fld>
             <a:endParaRPr lang="es-VE" altLang="es-VE"/>
           </a:p>
@@ -573,7 +573,7 @@
             <a:fld id="{C37E8F85-B729-4419-89BA-5F8E71B87271}" type="datetimeFigureOut">
               <a:rPr lang="es-VE" altLang="es-VE"/>
               <a:pPr/>
-              <a:t>6/3/2026</a:t>
+              <a:t>7/3/2026</a:t>
             </a:fld>
             <a:endParaRPr lang="es-VE" altLang="es-VE"/>
           </a:p>

</xml_diff>